<commit_message>
Refresh the walkthrough deck and add a project cover image
Two kinds of change.

Content: slide 5 now states the real place count in its honesty line, and
slide 6's queue subtitle says what the number actually is -- a range with a
stated confidence rather than a point estimate.

Presenter labels: every slide's note was labelled one member out of step
with the division table (topics that the table gives to A were labelled B,
B labelled C, and so on through F labelled A). All fourteen now match
项目纵览.md, so each presenter opens their own page and sees their own name.
Submission only rewrites note text; slide count and shape count are
unchanged (14 slides, 354 shapes before and after).

Also adds a 1280x640 cover for the GitHub social preview under docs/assets,
cut from the English home screen, and puts it at the top of the README.
</commit_message>
<xml_diff>
--- a/presentation/SmoothGo_Presentation.pptx
+++ b/presentation/SmoothGo_Presentation.pptx
@@ -455,7 +455,7 @@
           <a:lstStyle xmlns:a="http://schemas.openxmlformats.org/drawingml/2006/main"/>
           <a:p xmlns:a="http://schemas.openxmlformats.org/drawingml/2006/main">
             <a:r>
-              <a:t>OPEN (Member B · 0:00–0:25)</a:t>
+              <a:t>OPEN (Member A · 0:00–0:25)</a:t>
             </a:r>
           </a:p>
           <a:p xmlns:a="http://schemas.openxmlformats.org/drawingml/2006/main">
@@ -540,7 +540,7 @@
           <a:lstStyle xmlns:a="http://schemas.openxmlformats.org/drawingml/2006/main"/>
           <a:p xmlns:a="http://schemas.openxmlformats.org/drawingml/2006/main">
             <a:r>
-              <a:t>MARKETING (Member E · 10:45–11:45)</a:t>
+              <a:t>MARKETING (Member D · 10:45–11:45)</a:t>
             </a:r>
           </a:p>
           <a:p xmlns:a="http://schemas.openxmlformats.org/drawingml/2006/main">
@@ -620,7 +620,7 @@
           <a:lstStyle xmlns:a="http://schemas.openxmlformats.org/drawingml/2006/main"/>
           <a:p xmlns:a="http://schemas.openxmlformats.org/drawingml/2006/main">
             <a:r>
-              <a:t>FINANCE (Member D · 11:45–12:45)</a:t>
+              <a:t>FINANCE (Member C · 11:45–12:45)</a:t>
             </a:r>
           </a:p>
           <a:p xmlns:a="http://schemas.openxmlformats.org/drawingml/2006/main">
@@ -705,7 +705,7 @@
           <a:lstStyle xmlns:a="http://schemas.openxmlformats.org/drawingml/2006/main"/>
           <a:p xmlns:a="http://schemas.openxmlformats.org/drawingml/2006/main">
             <a:r>
-              <a:t>RISKS (Member F · 12:45–13:45)</a:t>
+              <a:t>RISKS (Member E · 12:45–13:45)</a:t>
             </a:r>
           </a:p>
           <a:p xmlns:a="http://schemas.openxmlformats.org/drawingml/2006/main">
@@ -785,7 +785,7 @@
           <a:lstStyle xmlns:a="http://schemas.openxmlformats.org/drawingml/2006/main"/>
           <a:p xmlns:a="http://schemas.openxmlformats.org/drawingml/2006/main">
             <a:r>
-              <a:t>CONCLUSION (Member F · 13:45–15:00)</a:t>
+              <a:t>CONCLUSION (Member E · 13:45–15:00)</a:t>
             </a:r>
           </a:p>
           <a:p xmlns:a="http://schemas.openxmlformats.org/drawingml/2006/main">
@@ -870,7 +870,7 @@
           <a:lstStyle xmlns:a="http://schemas.openxmlformats.org/drawingml/2006/main"/>
           <a:p xmlns:a="http://schemas.openxmlformats.org/drawingml/2006/main">
             <a:r>
-              <a:t>REFERENCES</a:t>
+              <a:t>REFERENCES (Member B)</a:t>
             </a:r>
           </a:p>
           <a:p xmlns:a="http://schemas.openxmlformats.org/drawingml/2006/main">
@@ -955,7 +955,7 @@
           <a:lstStyle xmlns:a="http://schemas.openxmlformats.org/drawingml/2006/main"/>
           <a:p xmlns:a="http://schemas.openxmlformats.org/drawingml/2006/main">
             <a:r>
-              <a:t>PROBLEM (Member B / Member C · 0:25–1:45)</a:t>
+              <a:t>PROBLEM (Member A · 0:25–1:45)</a:t>
             </a:r>
           </a:p>
           <a:p xmlns:a="http://schemas.openxmlformats.org/drawingml/2006/main">
@@ -1040,7 +1040,7 @@
           <a:lstStyle xmlns:a="http://schemas.openxmlformats.org/drawingml/2006/main"/>
           <a:p xmlns:a="http://schemas.openxmlformats.org/drawingml/2006/main">
             <a:r>
-              <a:t>SOLUTION (Member C · 1:45–2:45)</a:t>
+              <a:t>SOLUTION (Member A · 1:45–2:45)</a:t>
             </a:r>
           </a:p>
           <a:p xmlns:a="http://schemas.openxmlformats.org/drawingml/2006/main">
@@ -1125,7 +1125,7 @@
           <a:lstStyle xmlns:a="http://schemas.openxmlformats.org/drawingml/2006/main"/>
           <a:p xmlns:a="http://schemas.openxmlformats.org/drawingml/2006/main">
             <a:r>
-              <a:t>CUSTOMERS (Member C · 2:45–3:45)</a:t>
+              <a:t>CUSTOMERS (Member B · 2:45–3:45)</a:t>
             </a:r>
           </a:p>
           <a:p xmlns:a="http://schemas.openxmlformats.org/drawingml/2006/main">
@@ -1205,7 +1205,7 @@
           <a:lstStyle xmlns:a="http://schemas.openxmlformats.org/drawingml/2006/main"/>
           <a:p xmlns:a="http://schemas.openxmlformats.org/drawingml/2006/main">
             <a:r>
-              <a:t>DEMO (Member A · 3:45–6:15)</a:t>
+              <a:t>DEMO (Member F · 3:45–6:15)</a:t>
             </a:r>
           </a:p>
           <a:p xmlns:a="http://schemas.openxmlformats.org/drawingml/2006/main">
@@ -1290,7 +1290,7 @@
           <a:lstStyle xmlns:a="http://schemas.openxmlformats.org/drawingml/2006/main"/>
           <a:p xmlns:a="http://schemas.openxmlformats.org/drawingml/2006/main">
             <a:r>
-              <a:t>HOW IT WORKS (Member A · 6:15–7:15)</a:t>
+              <a:t>HOW IT WORKS (Member F · 6:15–7:15)</a:t>
             </a:r>
           </a:p>
           <a:p xmlns:a="http://schemas.openxmlformats.org/drawingml/2006/main">
@@ -1306,6 +1306,11 @@
           <a:p xmlns:a="http://schemas.openxmlformats.org/drawingml/2006/main">
             <a:r>
               <a:t>Explainability matters: the user can see why a stop was recommended.</a:t>
+            </a:r>
+          </a:p>
+          <a:p xmlns:a="http://schemas.openxmlformats.org/drawingml/2006/main">
+            <a:r>
+              <a:t>If asked about accuracy: every queue estimate is a range with a stated confidence, not a single number.</a:t>
             </a:r>
           </a:p>
         </p:txBody>
@@ -1375,7 +1380,7 @@
           <a:lstStyle xmlns:a="http://schemas.openxmlformats.org/drawingml/2006/main"/>
           <a:p xmlns:a="http://schemas.openxmlformats.org/drawingml/2006/main">
             <a:r>
-              <a:t>MARKET (Member C · 7:15–8:15)</a:t>
+              <a:t>MARKET (Member B · 7:15–8:15)</a:t>
             </a:r>
           </a:p>
           <a:p xmlns:a="http://schemas.openxmlformats.org/drawingml/2006/main">
@@ -1455,7 +1460,7 @@
           <a:lstStyle xmlns:a="http://schemas.openxmlformats.org/drawingml/2006/main"/>
           <a:p xmlns:a="http://schemas.openxmlformats.org/drawingml/2006/main">
             <a:r>
-              <a:t>BUSINESS MODEL (Member D · 8:15–9:45)</a:t>
+              <a:t>BUSINESS MODEL (Member C · 8:15–9:45)</a:t>
             </a:r>
           </a:p>
           <a:p xmlns:a="http://schemas.openxmlformats.org/drawingml/2006/main">
@@ -1540,7 +1545,7 @@
           <a:lstStyle xmlns:a="http://schemas.openxmlformats.org/drawingml/2006/main"/>
           <a:p xmlns:a="http://schemas.openxmlformats.org/drawingml/2006/main">
             <a:r>
-              <a:t>OPERATIONS (Member E · 9:45–10:45)</a:t>
+              <a:t>OPERATIONS (Member D · 9:45–10:45)</a:t>
             </a:r>
           </a:p>
           <a:p xmlns:a="http://schemas.openxmlformats.org/drawingml/2006/main">
@@ -14672,6 +14677,10 @@
           <a:effectRef xmlns:a="http://schemas.openxmlformats.org/drawingml/2006/main" idx="4"/>
           <a:fontRef xmlns:a="http://schemas.openxmlformats.org/drawingml/2006/main" idx="major"/>
         </p:style>
+        <p:txBody xmlns:a="http://schemas.openxmlformats.org/drawingml/2006/main">
+          <a:bodyPr/>
+          <a:p/>
+        </p:txBody>
       </p:sp>
       <p:sp>
         <p:nvSpPr>
@@ -14829,6 +14838,10 @@
             <a:prstDash val="solid"/>
           </a:ln>
         </p:spPr>
+        <p:txBody xmlns:a="http://schemas.openxmlformats.org/drawingml/2006/main">
+          <a:bodyPr/>
+          <a:p/>
+        </p:txBody>
       </p:sp>
       <p:sp>
         <p:nvSpPr>
@@ -14986,6 +14999,10 @@
             <a:prstDash val="solid"/>
           </a:ln>
         </p:spPr>
+        <p:txBody xmlns:a="http://schemas.openxmlformats.org/drawingml/2006/main">
+          <a:bodyPr/>
+          <a:p/>
+        </p:txBody>
       </p:sp>
       <p:sp>
         <p:nvSpPr>
@@ -15205,6 +15222,10 @@
             <a:prstDash val="solid"/>
           </a:ln>
         </p:spPr>
+        <p:txBody xmlns:a="http://schemas.openxmlformats.org/drawingml/2006/main">
+          <a:bodyPr/>
+          <a:p/>
+        </p:txBody>
       </p:sp>
       <p:sp>
         <p:nvSpPr>
@@ -15424,6 +15445,10 @@
             <a:prstDash val="solid"/>
           </a:ln>
         </p:spPr>
+        <p:txBody xmlns:a="http://schemas.openxmlformats.org/drawingml/2006/main">
+          <a:bodyPr/>
+          <a:p/>
+        </p:txBody>
       </p:sp>
       <p:sp>
         <p:nvSpPr>
@@ -15643,6 +15668,10 @@
             <a:prstDash val="solid"/>
           </a:ln>
         </p:spPr>
+        <p:txBody xmlns:a="http://schemas.openxmlformats.org/drawingml/2006/main">
+          <a:bodyPr/>
+          <a:p/>
+        </p:txBody>
       </p:sp>
       <p:sp>
         <p:nvSpPr>
@@ -15738,6 +15767,10 @@
             <a:prstDash val="solid"/>
           </a:ln>
         </p:spPr>
+        <p:txBody xmlns:a="http://schemas.openxmlformats.org/drawingml/2006/main">
+          <a:bodyPr/>
+          <a:p/>
+        </p:txBody>
       </p:sp>
       <p:sp>
         <p:nvSpPr>
@@ -15957,6 +15990,10 @@
             <a:prstDash val="solid"/>
           </a:ln>
         </p:spPr>
+        <p:txBody xmlns:a="http://schemas.openxmlformats.org/drawingml/2006/main">
+          <a:bodyPr/>
+          <a:p/>
+        </p:txBody>
       </p:sp>
       <p:sp>
         <p:nvSpPr>
@@ -16176,6 +16213,10 @@
             <a:prstDash val="solid"/>
           </a:ln>
         </p:spPr>
+        <p:txBody xmlns:a="http://schemas.openxmlformats.org/drawingml/2006/main">
+          <a:bodyPr/>
+          <a:p/>
+        </p:txBody>
       </p:sp>
       <p:sp>
         <p:nvSpPr>
@@ -16395,6 +16436,10 @@
             <a:prstDash val="solid"/>
           </a:ln>
         </p:spPr>
+        <p:txBody xmlns:a="http://schemas.openxmlformats.org/drawingml/2006/main">
+          <a:bodyPr/>
+          <a:p/>
+        </p:txBody>
       </p:sp>
       <p:sp>
         <p:nvSpPr>
@@ -16614,6 +16659,10 @@
             <a:prstDash val="solid"/>
           </a:ln>
         </p:spPr>
+        <p:txBody xmlns:a="http://schemas.openxmlformats.org/drawingml/2006/main">
+          <a:bodyPr/>
+          <a:p/>
+        </p:txBody>
       </p:sp>
       <p:sp>
         <p:nvSpPr>
@@ -16831,6 +16880,10 @@
             <a:prstDash val="solid"/>
           </a:ln>
         </p:spPr>
+        <p:txBody xmlns:a="http://schemas.openxmlformats.org/drawingml/2006/main">
+          <a:bodyPr/>
+          <a:p/>
+        </p:txBody>
       </p:sp>
       <p:sp>
         <p:nvSpPr>
@@ -16889,7 +16942,7 @@
                 <a:ea typeface="Arial"/>
                 <a:cs typeface="Arial"/>
               </a:rPr>
-              <a:t>Live prototype · illustrative data · no real bookings</a:t>
+              <a:t>Live prototype · 574 places · illustrative data · no bookings</a:t>
             </a:r>
           </a:p>
         </p:txBody>
@@ -16924,6 +16977,10 @@
             <a:prstDash val="solid"/>
           </a:ln>
         </p:spPr>
+        <p:txBody xmlns:a="http://schemas.openxmlformats.org/drawingml/2006/main">
+          <a:bodyPr/>
+          <a:p/>
+        </p:txBody>
       </p:sp>
       <p:sp>
         <p:nvSpPr>
@@ -17236,6 +17293,10 @@
             <a:prstDash val="solid"/>
           </a:ln>
         </p:spPr>
+        <p:txBody xmlns:a="http://schemas.openxmlformats.org/drawingml/2006/main">
+          <a:bodyPr/>
+          <a:p/>
+        </p:txBody>
       </p:sp>
       <p:sp>
         <p:nvSpPr>
@@ -17457,6 +17518,10 @@
             <a:prstDash val="solid"/>
           </a:ln>
         </p:spPr>
+        <p:txBody xmlns:a="http://schemas.openxmlformats.org/drawingml/2006/main">
+          <a:bodyPr/>
+          <a:p/>
+        </p:txBody>
       </p:sp>
       <p:sp>
         <p:nvSpPr>
@@ -17678,6 +17743,10 @@
             <a:prstDash val="solid"/>
           </a:ln>
         </p:spPr>
+        <p:txBody xmlns:a="http://schemas.openxmlformats.org/drawingml/2006/main">
+          <a:bodyPr/>
+          <a:p/>
+        </p:txBody>
       </p:sp>
       <p:sp>
         <p:nvSpPr>
@@ -17860,7 +17929,7 @@
                 <a:ea typeface="Arial"/>
                 <a:cs typeface="Arial"/>
               </a:rPr>
-              <a:t>How long will you actually wait?</a:t>
+              <a:t>A range, with a stated confidence.</a:t>
             </a:r>
           </a:p>
         </p:txBody>
@@ -17899,6 +17968,10 @@
             <a:prstDash val="solid"/>
           </a:ln>
         </p:spPr>
+        <p:txBody xmlns:a="http://schemas.openxmlformats.org/drawingml/2006/main">
+          <a:bodyPr/>
+          <a:p/>
+        </p:txBody>
       </p:sp>
       <p:sp>
         <p:nvSpPr>
@@ -18120,6 +18193,10 @@
             <a:prstDash val="solid"/>
           </a:ln>
         </p:spPr>
+        <p:txBody xmlns:a="http://schemas.openxmlformats.org/drawingml/2006/main">
+          <a:bodyPr/>
+          <a:p/>
+        </p:txBody>
       </p:sp>
       <p:sp>
         <p:nvSpPr>
@@ -18341,6 +18418,10 @@
             <a:prstDash val="solid"/>
           </a:ln>
         </p:spPr>
+        <p:txBody xmlns:a="http://schemas.openxmlformats.org/drawingml/2006/main">
+          <a:bodyPr/>
+          <a:p/>
+        </p:txBody>
       </p:sp>
       <p:sp>
         <p:nvSpPr>
@@ -18562,6 +18643,10 @@
             <a:prstDash val="solid"/>
           </a:ln>
         </p:spPr>
+        <p:txBody xmlns:a="http://schemas.openxmlformats.org/drawingml/2006/main">
+          <a:bodyPr/>
+          <a:p/>
+        </p:txBody>
       </p:sp>
       <p:sp>
         <p:nvSpPr>
@@ -18717,6 +18802,10 @@
             <a:prstDash val="solid"/>
           </a:ln>
         </p:spPr>
+        <p:txBody xmlns:a="http://schemas.openxmlformats.org/drawingml/2006/main">
+          <a:bodyPr/>
+          <a:p/>
+        </p:txBody>
       </p:sp>
       <p:sp>
         <p:nvSpPr>
@@ -18810,6 +18899,10 @@
             <a:prstDash val="solid"/>
           </a:ln>
         </p:spPr>
+        <p:txBody xmlns:a="http://schemas.openxmlformats.org/drawingml/2006/main">
+          <a:bodyPr/>
+          <a:p/>
+        </p:txBody>
       </p:sp>
       <p:sp>
         <p:nvSpPr>

</xml_diff>